<commit_message>
fix: restore collaborative design and adaptive layouts in v0.9.1
Restore source, storyline, pilot and final-review checkpoints with scoped delegation. Fit cards to content, inspect whitespace and contrast, and provide usable dark and partial-fill academic palettes.

Include official DSH runtime injection checks and an exact-commit verified release workflow.
</commit_message>
<xml_diff>
--- a/skills/dsh-academic-ppt/references/card-library/figure-cards.pptx
+++ b/skills/dsh-academic-ppt/references/card-library/figure-cards.pptx
@@ -2115,11 +2115,11 @@
         <p:spPr>
           <a:xfrm>
             <a:off x="762000" y="1409700"/>
-            <a:ext cx="10668000" cy="4031361"/>
+            <a:ext cx="10668000" cy="4876800"/>
           </a:xfrm>
           <a:prstGeom prst="roundRect">
             <a:avLst>
-              <a:gd name="adj" fmla="val 214"/>
+              <a:gd name="adj" fmla="val 146"/>
             </a:avLst>
           </a:prstGeom>
           <a:solidFill>
@@ -2141,7 +2141,7 @@
         </p:nvSpPr>
         <p:spPr>
           <a:xfrm>
-            <a:off x="952500" y="4876419"/>
+            <a:off x="952500" y="5721858"/>
             <a:ext cx="10287000" cy="0"/>
           </a:xfrm>
           <a:prstGeom prst="line">
@@ -2206,7 +2206,7 @@
         </p:nvSpPr>
         <p:spPr>
           <a:xfrm>
-            <a:off x="952500" y="4459605"/>
+            <a:off x="952500" y="5305044"/>
             <a:ext cx="10287000" cy="283464"/>
           </a:xfrm>
           <a:prstGeom prst="rect">
@@ -2248,7 +2248,7 @@
         </p:nvSpPr>
         <p:spPr>
           <a:xfrm>
-            <a:off x="952500" y="4971669"/>
+            <a:off x="952500" y="5817108"/>
             <a:ext cx="10287000" cy="278892"/>
           </a:xfrm>
           <a:prstGeom prst="rect">
@@ -2298,8 +2298,8 @@
         </p:blipFill>
         <p:spPr>
           <a:xfrm>
-            <a:off x="2976677" y="2040255"/>
-            <a:ext cx="6238646" cy="1949577"/>
+            <a:off x="1623974" y="2040255"/>
+            <a:ext cx="8944051" cy="2795016"/>
           </a:xfrm>
           <a:prstGeom prst="rect">
             <a:avLst/>
@@ -2314,7 +2314,7 @@
         </p:nvSpPr>
         <p:spPr>
           <a:xfrm>
-            <a:off x="952500" y="4075557"/>
+            <a:off x="952500" y="4920996"/>
             <a:ext cx="10287000" cy="250698"/>
           </a:xfrm>
           <a:prstGeom prst="rect">
@@ -2473,11 +2473,11 @@
         <p:spPr>
           <a:xfrm>
             <a:off x="762000" y="1409700"/>
-            <a:ext cx="10668000" cy="3752469"/>
+            <a:ext cx="10668000" cy="3510010"/>
           </a:xfrm>
           <a:prstGeom prst="roundRect">
             <a:avLst>
-              <a:gd name="adj" fmla="val 247"/>
+              <a:gd name="adj" fmla="val 283"/>
             </a:avLst>
           </a:prstGeom>
           <a:solidFill>
@@ -2759,7 +2759,7 @@
         </p:blipFill>
         <p:spPr>
           <a:xfrm>
-            <a:off x="3212211" y="2578298"/>
+            <a:off x="3212211" y="2457069"/>
             <a:ext cx="5767578" cy="1802368"/>
           </a:xfrm>
           <a:prstGeom prst="rect">
@@ -2775,7 +2775,7 @@
         </p:nvSpPr>
         <p:spPr>
           <a:xfrm>
-            <a:off x="3212211" y="4587621"/>
+            <a:off x="3212211" y="4345162"/>
             <a:ext cx="5767578" cy="250698"/>
           </a:xfrm>
           <a:prstGeom prst="rect">
@@ -2934,11 +2934,11 @@
         <p:spPr>
           <a:xfrm>
             <a:off x="762000" y="1409700"/>
-            <a:ext cx="10668000" cy="4265295"/>
+            <a:ext cx="10668000" cy="4876799"/>
           </a:xfrm>
           <a:prstGeom prst="roundRect">
             <a:avLst>
-              <a:gd name="adj" fmla="val 191"/>
+              <a:gd name="adj" fmla="val 146"/>
             </a:avLst>
           </a:prstGeom>
           <a:solidFill>
@@ -2960,7 +2960,7 @@
         </p:nvSpPr>
         <p:spPr>
           <a:xfrm>
-            <a:off x="952500" y="4266819"/>
+            <a:off x="952500" y="4878323"/>
             <a:ext cx="10287000" cy="0"/>
           </a:xfrm>
           <a:prstGeom prst="line">
@@ -2983,7 +2983,7 @@
         </p:nvSpPr>
         <p:spPr>
           <a:xfrm>
-            <a:off x="952500" y="5110353"/>
+            <a:off x="952500" y="5721857"/>
             <a:ext cx="10287000" cy="0"/>
           </a:xfrm>
           <a:prstGeom prst="line">
@@ -3090,7 +3090,7 @@
         </p:nvSpPr>
         <p:spPr>
           <a:xfrm>
-            <a:off x="952500" y="4371594"/>
+            <a:off x="952500" y="4983098"/>
             <a:ext cx="5057775" cy="278892"/>
           </a:xfrm>
           <a:prstGeom prst="rect">
@@ -3132,7 +3132,7 @@
         </p:nvSpPr>
         <p:spPr>
           <a:xfrm>
-            <a:off x="952500" y="4698111"/>
+            <a:off x="952500" y="5309615"/>
             <a:ext cx="5057775" cy="278892"/>
           </a:xfrm>
           <a:prstGeom prst="rect">
@@ -3174,7 +3174,7 @@
         </p:nvSpPr>
         <p:spPr>
           <a:xfrm>
-            <a:off x="6181725" y="4371594"/>
+            <a:off x="6181725" y="4983098"/>
             <a:ext cx="5057775" cy="278892"/>
           </a:xfrm>
           <a:prstGeom prst="rect">
@@ -3216,7 +3216,7 @@
         </p:nvSpPr>
         <p:spPr>
           <a:xfrm>
-            <a:off x="6181725" y="4698111"/>
+            <a:off x="6181725" y="5309615"/>
             <a:ext cx="5057775" cy="278892"/>
           </a:xfrm>
           <a:prstGeom prst="rect">
@@ -3258,7 +3258,7 @@
         </p:nvSpPr>
         <p:spPr>
           <a:xfrm>
-            <a:off x="952500" y="5205603"/>
+            <a:off x="952500" y="5817107"/>
             <a:ext cx="10287000" cy="278892"/>
           </a:xfrm>
           <a:prstGeom prst="rect">
@@ -3308,8 +3308,8 @@
         </p:blipFill>
         <p:spPr>
           <a:xfrm>
-            <a:off x="3891077" y="2457069"/>
-            <a:ext cx="4409846" cy="1378077"/>
+            <a:off x="2912670" y="2457069"/>
+            <a:ext cx="6366661" cy="1989581"/>
           </a:xfrm>
           <a:prstGeom prst="rect">
             <a:avLst/>
@@ -3324,7 +3324,7 @@
         </p:nvSpPr>
         <p:spPr>
           <a:xfrm>
-            <a:off x="952500" y="3920871"/>
+            <a:off x="952500" y="4532375"/>
             <a:ext cx="10287000" cy="250698"/>
           </a:xfrm>
           <a:prstGeom prst="rect">
@@ -3483,11 +3483,11 @@
         <p:spPr>
           <a:xfrm>
             <a:off x="762000" y="1409700"/>
-            <a:ext cx="10668000" cy="4703445"/>
+            <a:ext cx="10668000" cy="4876800"/>
           </a:xfrm>
           <a:prstGeom prst="roundRect">
             <a:avLst>
-              <a:gd name="adj" fmla="val 157"/>
+              <a:gd name="adj" fmla="val 146"/>
             </a:avLst>
           </a:prstGeom>
           <a:solidFill>
@@ -3518,13 +3518,8 @@
           <a:solidFill>
             <a:srgbClr val="F2F6F8"/>
           </a:solidFill>
-          <a:ln w="12700">
-            <a:solidFill>
-              <a:srgbClr val="FFFFFF">
-                <a:alpha val="0"/>
-              </a:srgbClr>
-            </a:solidFill>
-            <a:prstDash val="solid"/>
+          <a:ln>
+            <a:noFill/>
           </a:ln>
         </p:spPr>
       </p:sp>
@@ -3536,7 +3531,7 @@
         </p:nvSpPr>
         <p:spPr>
           <a:xfrm>
-            <a:off x="952500" y="5548503"/>
+            <a:off x="952500" y="5721858"/>
             <a:ext cx="10287000" cy="0"/>
           </a:xfrm>
           <a:prstGeom prst="line">
@@ -3811,7 +3806,7 @@
         </p:nvSpPr>
         <p:spPr>
           <a:xfrm>
-            <a:off x="952500" y="5643753"/>
+            <a:off x="952500" y="5817108"/>
             <a:ext cx="10287000" cy="278892"/>
           </a:xfrm>
           <a:prstGeom prst="rect">
@@ -3861,8 +3856,8 @@
         </p:blipFill>
         <p:spPr>
           <a:xfrm>
-            <a:off x="3433877" y="3414903"/>
-            <a:ext cx="5324246" cy="1663827"/>
+            <a:off x="3156509" y="3414903"/>
+            <a:ext cx="5878981" cy="1837182"/>
           </a:xfrm>
           <a:prstGeom prst="rect">
             <a:avLst/>
@@ -3877,7 +3872,7 @@
         </p:nvSpPr>
         <p:spPr>
           <a:xfrm>
-            <a:off x="952500" y="5164455"/>
+            <a:off x="952500" y="5337810"/>
             <a:ext cx="10287000" cy="250698"/>
           </a:xfrm>
           <a:prstGeom prst="rect">
@@ -4036,11 +4031,11 @@
         <p:spPr>
           <a:xfrm>
             <a:off x="762000" y="1409700"/>
-            <a:ext cx="10668000" cy="3709797"/>
+            <a:ext cx="10668000" cy="3688080"/>
           </a:xfrm>
           <a:prstGeom prst="roundRect">
             <a:avLst>
-              <a:gd name="adj" fmla="val 253"/>
+              <a:gd name="adj" fmla="val 256"/>
             </a:avLst>
           </a:prstGeom>
           <a:solidFill>
@@ -4062,7 +4057,7 @@
         </p:nvSpPr>
         <p:spPr>
           <a:xfrm>
-            <a:off x="952500" y="4554855"/>
+            <a:off x="952500" y="4533138"/>
             <a:ext cx="10287000" cy="0"/>
           </a:xfrm>
           <a:prstGeom prst="line">
@@ -4273,7 +4268,7 @@
         </p:nvSpPr>
         <p:spPr>
           <a:xfrm>
-            <a:off x="952500" y="4650105"/>
+            <a:off x="952500" y="4628388"/>
             <a:ext cx="10287000" cy="278892"/>
           </a:xfrm>
           <a:prstGeom prst="rect">
@@ -4323,7 +4318,7 @@
         </p:blipFill>
         <p:spPr>
           <a:xfrm>
-            <a:off x="952500" y="2051113"/>
+            <a:off x="952500" y="2040255"/>
             <a:ext cx="6473952" cy="2023110"/>
           </a:xfrm>
           <a:prstGeom prst="rect">
@@ -4339,7 +4334,7 @@
         </p:nvSpPr>
         <p:spPr>
           <a:xfrm>
-            <a:off x="952500" y="4170807"/>
+            <a:off x="952500" y="4149090"/>
             <a:ext cx="6473952" cy="250698"/>
           </a:xfrm>
           <a:prstGeom prst="rect">
@@ -4498,11 +4493,11 @@
         <p:spPr>
           <a:xfrm>
             <a:off x="762000" y="1409700"/>
-            <a:ext cx="10668000" cy="3709797"/>
+            <a:ext cx="10668000" cy="3688080"/>
           </a:xfrm>
           <a:prstGeom prst="roundRect">
             <a:avLst>
-              <a:gd name="adj" fmla="val 253"/>
+              <a:gd name="adj" fmla="val 256"/>
             </a:avLst>
           </a:prstGeom>
           <a:solidFill>
@@ -4524,7 +4519,7 @@
         </p:nvSpPr>
         <p:spPr>
           <a:xfrm>
-            <a:off x="952500" y="4554855"/>
+            <a:off x="952500" y="4533138"/>
             <a:ext cx="10287000" cy="0"/>
           </a:xfrm>
           <a:prstGeom prst="line">
@@ -4715,7 +4710,7 @@
         </p:nvSpPr>
         <p:spPr>
           <a:xfrm>
-            <a:off x="952500" y="4650105"/>
+            <a:off x="952500" y="4628388"/>
             <a:ext cx="10287000" cy="278892"/>
           </a:xfrm>
           <a:prstGeom prst="rect">
@@ -4765,7 +4760,7 @@
         </p:blipFill>
         <p:spPr>
           <a:xfrm>
-            <a:off x="4765548" y="2051113"/>
+            <a:off x="4765548" y="2040255"/>
             <a:ext cx="6473952" cy="2023110"/>
           </a:xfrm>
           <a:prstGeom prst="rect">
@@ -4781,7 +4776,7 @@
         </p:nvSpPr>
         <p:spPr>
           <a:xfrm>
-            <a:off x="4765548" y="4170807"/>
+            <a:off x="4765548" y="4149090"/>
             <a:ext cx="6473952" cy="250698"/>
           </a:xfrm>
           <a:prstGeom prst="rect">
@@ -4940,11 +4935,11 @@
         <p:spPr>
           <a:xfrm>
             <a:off x="762000" y="1409700"/>
-            <a:ext cx="10668000" cy="4031361"/>
+            <a:ext cx="10668000" cy="3662339"/>
           </a:xfrm>
           <a:prstGeom prst="roundRect">
             <a:avLst>
-              <a:gd name="adj" fmla="val 214"/>
+              <a:gd name="adj" fmla="val 260"/>
             </a:avLst>
           </a:prstGeom>
           <a:solidFill>
@@ -4966,7 +4961,7 @@
         </p:nvSpPr>
         <p:spPr>
           <a:xfrm>
-            <a:off x="952500" y="4876419"/>
+            <a:off x="952500" y="4507397"/>
             <a:ext cx="10287000" cy="0"/>
           </a:xfrm>
           <a:prstGeom prst="line">
@@ -5073,7 +5068,7 @@
         </p:nvSpPr>
         <p:spPr>
           <a:xfrm>
-            <a:off x="952500" y="4971669"/>
+            <a:off x="952500" y="4602647"/>
             <a:ext cx="10287000" cy="278892"/>
           </a:xfrm>
           <a:prstGeom prst="rect">
@@ -5123,7 +5118,7 @@
         </p:blipFill>
         <p:spPr>
           <a:xfrm>
-            <a:off x="952500" y="2641580"/>
+            <a:off x="952500" y="2457069"/>
             <a:ext cx="5057775" cy="1580555"/>
           </a:xfrm>
           <a:prstGeom prst="rect">
@@ -5139,7 +5134,7 @@
         </p:nvSpPr>
         <p:spPr>
           <a:xfrm>
-            <a:off x="952500" y="4492371"/>
+            <a:off x="952500" y="4123349"/>
             <a:ext cx="5057775" cy="250698"/>
           </a:xfrm>
           <a:prstGeom prst="rect">
@@ -5189,7 +5184,7 @@
         </p:blipFill>
         <p:spPr>
           <a:xfrm>
-            <a:off x="6181725" y="2641580"/>
+            <a:off x="6181725" y="2457069"/>
             <a:ext cx="5057775" cy="1580555"/>
           </a:xfrm>
           <a:prstGeom prst="rect">
@@ -5205,7 +5200,7 @@
         </p:nvSpPr>
         <p:spPr>
           <a:xfrm>
-            <a:off x="6181725" y="4492371"/>
+            <a:off x="6181725" y="4123349"/>
             <a:ext cx="5057775" cy="250698"/>
           </a:xfrm>
           <a:prstGeom prst="rect">
@@ -5364,11 +5359,11 @@
         <p:spPr>
           <a:xfrm>
             <a:off x="762000" y="1409700"/>
-            <a:ext cx="10668000" cy="4133469"/>
+            <a:ext cx="10668000" cy="4876800"/>
           </a:xfrm>
           <a:prstGeom prst="roundRect">
             <a:avLst>
-              <a:gd name="adj" fmla="val 204"/>
+              <a:gd name="adj" fmla="val 146"/>
             </a:avLst>
           </a:prstGeom>
           <a:solidFill>
@@ -5558,7 +5553,7 @@
         </p:nvSpPr>
         <p:spPr>
           <a:xfrm>
-            <a:off x="8002524" y="3923919"/>
+            <a:off x="8002524" y="4295584"/>
             <a:ext cx="3236976" cy="278892"/>
           </a:xfrm>
           <a:prstGeom prst="rect">
@@ -5600,7 +5595,7 @@
         </p:nvSpPr>
         <p:spPr>
           <a:xfrm>
-            <a:off x="8002524" y="4250436"/>
+            <a:off x="8002524" y="4622101"/>
             <a:ext cx="3236976" cy="278892"/>
           </a:xfrm>
           <a:prstGeom prst="rect">
@@ -5650,8 +5645,8 @@
         </p:blipFill>
         <p:spPr>
           <a:xfrm>
-            <a:off x="2857424" y="2457069"/>
-            <a:ext cx="3068726" cy="958977"/>
+            <a:off x="2262759" y="2457069"/>
+            <a:ext cx="4258056" cy="1330642"/>
           </a:xfrm>
           <a:prstGeom prst="rect">
             <a:avLst/>
@@ -5666,7 +5661,7 @@
         </p:nvSpPr>
         <p:spPr>
           <a:xfrm>
-            <a:off x="952500" y="3501771"/>
+            <a:off x="952500" y="3873436"/>
             <a:ext cx="6878574" cy="250698"/>
           </a:xfrm>
           <a:prstGeom prst="rect">
@@ -5716,8 +5711,8 @@
         </p:blipFill>
         <p:spPr>
           <a:xfrm>
-            <a:off x="2857424" y="3923919"/>
-            <a:ext cx="3068726" cy="958977"/>
+            <a:off x="2262759" y="4295584"/>
+            <a:ext cx="4258056" cy="1330642"/>
           </a:xfrm>
           <a:prstGeom prst="rect">
             <a:avLst/>
@@ -5732,7 +5727,7 @@
         </p:nvSpPr>
         <p:spPr>
           <a:xfrm>
-            <a:off x="952500" y="4968621"/>
+            <a:off x="952500" y="5711952"/>
             <a:ext cx="6878574" cy="250698"/>
           </a:xfrm>
           <a:prstGeom prst="rect">
@@ -5891,11 +5886,11 @@
         <p:spPr>
           <a:xfrm>
             <a:off x="762000" y="1409700"/>
-            <a:ext cx="10668000" cy="4110228"/>
+            <a:ext cx="10668000" cy="3784663"/>
           </a:xfrm>
           <a:prstGeom prst="roundRect">
             <a:avLst>
-              <a:gd name="adj" fmla="val 206"/>
+              <a:gd name="adj" fmla="val 243"/>
             </a:avLst>
           </a:prstGeom>
           <a:solidFill>
@@ -5917,7 +5912,7 @@
         </p:nvSpPr>
         <p:spPr>
           <a:xfrm>
-            <a:off x="952500" y="4955286"/>
+            <a:off x="952500" y="4629721"/>
             <a:ext cx="10287000" cy="0"/>
           </a:xfrm>
           <a:prstGeom prst="line">
@@ -6024,7 +6019,7 @@
         </p:nvSpPr>
         <p:spPr>
           <a:xfrm>
-            <a:off x="952500" y="4495419"/>
+            <a:off x="952500" y="4169854"/>
             <a:ext cx="3314700" cy="278892"/>
           </a:xfrm>
           <a:prstGeom prst="rect">
@@ -6066,7 +6061,7 @@
         </p:nvSpPr>
         <p:spPr>
           <a:xfrm>
-            <a:off x="4438650" y="4495419"/>
+            <a:off x="4438650" y="4169854"/>
             <a:ext cx="3314700" cy="278892"/>
           </a:xfrm>
           <a:prstGeom prst="rect">
@@ -6108,7 +6103,7 @@
         </p:nvSpPr>
         <p:spPr>
           <a:xfrm>
-            <a:off x="7924800" y="4495419"/>
+            <a:off x="7924800" y="4169854"/>
             <a:ext cx="3314700" cy="278892"/>
           </a:xfrm>
           <a:prstGeom prst="rect">
@@ -6150,7 +6145,7 @@
         </p:nvSpPr>
         <p:spPr>
           <a:xfrm>
-            <a:off x="952500" y="5050536"/>
+            <a:off x="952500" y="4724972"/>
             <a:ext cx="10287000" cy="278892"/>
           </a:xfrm>
           <a:prstGeom prst="rect">
@@ -6200,7 +6195,7 @@
         </p:blipFill>
         <p:spPr>
           <a:xfrm>
-            <a:off x="952500" y="2723436"/>
+            <a:off x="952500" y="2560653"/>
             <a:ext cx="3314700" cy="1035844"/>
           </a:xfrm>
           <a:prstGeom prst="rect">
@@ -6216,7 +6211,7 @@
         </p:nvSpPr>
         <p:spPr>
           <a:xfrm>
-            <a:off x="952500" y="4111371"/>
+            <a:off x="952500" y="3785806"/>
             <a:ext cx="3314700" cy="250698"/>
           </a:xfrm>
           <a:prstGeom prst="rect">
@@ -6266,7 +6261,7 @@
         </p:blipFill>
         <p:spPr>
           <a:xfrm>
-            <a:off x="4438650" y="2723436"/>
+            <a:off x="4438650" y="2560653"/>
             <a:ext cx="3314700" cy="1035844"/>
           </a:xfrm>
           <a:prstGeom prst="rect">
@@ -6282,7 +6277,7 @@
         </p:nvSpPr>
         <p:spPr>
           <a:xfrm>
-            <a:off x="4438650" y="4111371"/>
+            <a:off x="4438650" y="3785806"/>
             <a:ext cx="3314700" cy="250698"/>
           </a:xfrm>
           <a:prstGeom prst="rect">
@@ -6331,7 +6326,7 @@
         </p:blipFill>
         <p:spPr>
           <a:xfrm>
-            <a:off x="7924800" y="2619851"/>
+            <a:off x="7924800" y="2457069"/>
             <a:ext cx="3314700" cy="1243013"/>
           </a:xfrm>
           <a:prstGeom prst="rect">
@@ -6347,7 +6342,7 @@
         </p:nvSpPr>
         <p:spPr>
           <a:xfrm>
-            <a:off x="7924800" y="4111371"/>
+            <a:off x="7924800" y="3785806"/>
             <a:ext cx="3314700" cy="250698"/>
           </a:xfrm>
           <a:prstGeom prst="rect">
@@ -6506,11 +6501,11 @@
         <p:spPr>
           <a:xfrm>
             <a:off x="762000" y="1409700"/>
-            <a:ext cx="10668000" cy="4698111"/>
+            <a:ext cx="10668000" cy="4876800"/>
           </a:xfrm>
           <a:prstGeom prst="roundRect">
             <a:avLst>
-              <a:gd name="adj" fmla="val 158"/>
+              <a:gd name="adj" fmla="val 146"/>
             </a:avLst>
           </a:prstGeom>
           <a:solidFill>
@@ -6532,7 +6527,7 @@
         </p:nvSpPr>
         <p:spPr>
           <a:xfrm>
-            <a:off x="952500" y="5543169"/>
+            <a:off x="952500" y="5721858"/>
             <a:ext cx="10287000" cy="0"/>
           </a:xfrm>
           <a:prstGeom prst="line">
@@ -6639,7 +6634,7 @@
         </p:nvSpPr>
         <p:spPr>
           <a:xfrm>
-            <a:off x="952500" y="5638419"/>
+            <a:off x="952500" y="5817108"/>
             <a:ext cx="10287000" cy="278892"/>
           </a:xfrm>
           <a:prstGeom prst="rect">
@@ -6689,8 +6684,8 @@
         </p:blipFill>
         <p:spPr>
           <a:xfrm>
-            <a:off x="1794624" y="2457069"/>
-            <a:ext cx="3373526" cy="1054227"/>
+            <a:off x="1651673" y="2457069"/>
+            <a:ext cx="3659428" cy="1143571"/>
           </a:xfrm>
           <a:prstGeom prst="rect">
             <a:avLst/>
@@ -6705,7 +6700,7 @@
         </p:nvSpPr>
         <p:spPr>
           <a:xfrm>
-            <a:off x="952500" y="3597021"/>
+            <a:off x="952500" y="3686365"/>
             <a:ext cx="5057775" cy="250698"/>
           </a:xfrm>
           <a:prstGeom prst="rect">
@@ -6755,8 +6750,8 @@
         </p:blipFill>
         <p:spPr>
           <a:xfrm>
-            <a:off x="7023849" y="2457069"/>
-            <a:ext cx="3373526" cy="1054227"/>
+            <a:off x="6880898" y="2457069"/>
+            <a:ext cx="3659428" cy="1143571"/>
           </a:xfrm>
           <a:prstGeom prst="rect">
             <a:avLst/>
@@ -6771,7 +6766,7 @@
         </p:nvSpPr>
         <p:spPr>
           <a:xfrm>
-            <a:off x="6181725" y="3597021"/>
+            <a:off x="6181725" y="3686365"/>
             <a:ext cx="5057775" cy="250698"/>
           </a:xfrm>
           <a:prstGeom prst="rect">
@@ -6821,8 +6816,8 @@
         </p:blipFill>
         <p:spPr>
           <a:xfrm>
-            <a:off x="1794624" y="4019169"/>
-            <a:ext cx="3373526" cy="1054227"/>
+            <a:off x="1651673" y="4108513"/>
+            <a:ext cx="3659428" cy="1143571"/>
           </a:xfrm>
           <a:prstGeom prst="rect">
             <a:avLst/>
@@ -6837,7 +6832,7 @@
         </p:nvSpPr>
         <p:spPr>
           <a:xfrm>
-            <a:off x="952500" y="5159121"/>
+            <a:off x="952500" y="5337810"/>
             <a:ext cx="5057775" cy="250698"/>
           </a:xfrm>
           <a:prstGeom prst="rect">
@@ -6886,8 +6881,8 @@
         </p:blipFill>
         <p:spPr>
           <a:xfrm>
-            <a:off x="7304977" y="4019169"/>
-            <a:ext cx="2811272" cy="1054227"/>
+            <a:off x="7185851" y="4108513"/>
+            <a:ext cx="3049524" cy="1143571"/>
           </a:xfrm>
           <a:prstGeom prst="rect">
             <a:avLst/>
@@ -6902,7 +6897,7 @@
         </p:nvSpPr>
         <p:spPr>
           <a:xfrm>
-            <a:off x="6181725" y="5159121"/>
+            <a:off x="6181725" y="5337810"/>
             <a:ext cx="5057775" cy="250698"/>
           </a:xfrm>
           <a:prstGeom prst="rect">
@@ -7061,11 +7056,11 @@
         <p:spPr>
           <a:xfrm>
             <a:off x="762000" y="1409700"/>
-            <a:ext cx="10668000" cy="4031361"/>
+            <a:ext cx="10668000" cy="4189190"/>
           </a:xfrm>
           <a:prstGeom prst="roundRect">
             <a:avLst>
-              <a:gd name="adj" fmla="val 214"/>
+              <a:gd name="adj" fmla="val 199"/>
             </a:avLst>
           </a:prstGeom>
           <a:solidFill>
@@ -7087,7 +7082,7 @@
         </p:nvSpPr>
         <p:spPr>
           <a:xfrm>
-            <a:off x="952500" y="4876419"/>
+            <a:off x="952500" y="5034248"/>
             <a:ext cx="10287000" cy="0"/>
           </a:xfrm>
           <a:prstGeom prst="line">
@@ -7194,7 +7189,7 @@
         </p:nvSpPr>
         <p:spPr>
           <a:xfrm>
-            <a:off x="952500" y="4971669"/>
+            <a:off x="952500" y="5129498"/>
             <a:ext cx="10287000" cy="278892"/>
           </a:xfrm>
           <a:prstGeom prst="rect">
@@ -7244,8 +7239,8 @@
         </p:blipFill>
         <p:spPr>
           <a:xfrm>
-            <a:off x="1205027" y="2457069"/>
-            <a:ext cx="6238646" cy="1949577"/>
+            <a:off x="952500" y="2457069"/>
+            <a:ext cx="6743700" cy="2107406"/>
           </a:xfrm>
           <a:prstGeom prst="rect">
             <a:avLst/>
@@ -7260,7 +7255,7 @@
         </p:nvSpPr>
         <p:spPr>
           <a:xfrm>
-            <a:off x="952500" y="4492371"/>
+            <a:off x="952500" y="4650200"/>
             <a:ext cx="6743700" cy="250698"/>
           </a:xfrm>
           <a:prstGeom prst="rect">
@@ -7309,7 +7304,7 @@
         </p:blipFill>
         <p:spPr>
           <a:xfrm>
-            <a:off x="7867650" y="2799636"/>
+            <a:off x="7867650" y="2878550"/>
             <a:ext cx="3371850" cy="1264444"/>
           </a:xfrm>
           <a:prstGeom prst="rect">
@@ -7325,7 +7320,7 @@
         </p:nvSpPr>
         <p:spPr>
           <a:xfrm>
-            <a:off x="7867650" y="4492371"/>
+            <a:off x="7867650" y="4650200"/>
             <a:ext cx="3371850" cy="250698"/>
           </a:xfrm>
           <a:prstGeom prst="rect">
@@ -7484,11 +7479,11 @@
         <p:spPr>
           <a:xfrm>
             <a:off x="762000" y="1409700"/>
-            <a:ext cx="10668000" cy="4698111"/>
+            <a:ext cx="10668000" cy="4876799"/>
           </a:xfrm>
           <a:prstGeom prst="roundRect">
             <a:avLst>
-              <a:gd name="adj" fmla="val 158"/>
+              <a:gd name="adj" fmla="val 146"/>
             </a:avLst>
           </a:prstGeom>
           <a:solidFill>
@@ -7510,7 +7505,7 @@
         </p:nvSpPr>
         <p:spPr>
           <a:xfrm>
-            <a:off x="952500" y="5543169"/>
+            <a:off x="952500" y="5721857"/>
             <a:ext cx="10287000" cy="0"/>
           </a:xfrm>
           <a:prstGeom prst="line">
@@ -7617,7 +7612,7 @@
         </p:nvSpPr>
         <p:spPr>
           <a:xfrm>
-            <a:off x="952500" y="5638419"/>
+            <a:off x="952500" y="5817107"/>
             <a:ext cx="10287000" cy="278892"/>
           </a:xfrm>
           <a:prstGeom prst="rect">
@@ -7667,8 +7662,8 @@
         </p:blipFill>
         <p:spPr>
           <a:xfrm>
-            <a:off x="4498238" y="2457069"/>
-            <a:ext cx="3195523" cy="998601"/>
+            <a:off x="3726702" y="2457069"/>
+            <a:ext cx="4738596" cy="1480811"/>
           </a:xfrm>
           <a:prstGeom prst="rect">
             <a:avLst/>
@@ -7683,7 +7678,7 @@
         </p:nvSpPr>
         <p:spPr>
           <a:xfrm>
-            <a:off x="952500" y="3541395"/>
+            <a:off x="952500" y="4023605"/>
             <a:ext cx="10287000" cy="250698"/>
           </a:xfrm>
           <a:prstGeom prst="rect">
@@ -7733,8 +7728,8 @@
         </p:blipFill>
         <p:spPr>
           <a:xfrm>
-            <a:off x="1705623" y="3963543"/>
-            <a:ext cx="3551530" cy="1109853"/>
+            <a:off x="2191258" y="4445753"/>
+            <a:ext cx="2580259" cy="806331"/>
           </a:xfrm>
           <a:prstGeom prst="rect">
             <a:avLst/>
@@ -7749,7 +7744,7 @@
         </p:nvSpPr>
         <p:spPr>
           <a:xfrm>
-            <a:off x="952500" y="5159121"/>
+            <a:off x="952500" y="5337809"/>
             <a:ext cx="5057775" cy="250698"/>
           </a:xfrm>
           <a:prstGeom prst="rect">
@@ -7798,8 +7793,8 @@
         </p:blipFill>
         <p:spPr>
           <a:xfrm>
-            <a:off x="7230809" y="3963543"/>
-            <a:ext cx="2959608" cy="1109853"/>
+            <a:off x="7635505" y="4445753"/>
+            <a:ext cx="2150216" cy="806331"/>
           </a:xfrm>
           <a:prstGeom prst="rect">
             <a:avLst/>
@@ -7814,7 +7809,7 @@
         </p:nvSpPr>
         <p:spPr>
           <a:xfrm>
-            <a:off x="6181725" y="5159121"/>
+            <a:off x="6181725" y="5337809"/>
             <a:ext cx="5057775" cy="250698"/>
           </a:xfrm>
           <a:prstGeom prst="rect">

</xml_diff>